<commit_message>
fix(ptc-art): kabul testi MinIO rotasını ölçemiyordu — IP'yi dışarıdan al
Güvenlik sondası MinIO'nun adresini `MINIO_PORT_9000_TCP_ADDR`'den
okuyordu. `enableServiceLinks: false` konunca o değişken kalktı ve sonda
`KeyError` veriyordu. `proxy` kipinde kontrol yine PASS diyordu — ama
yanlış sebeple: "rota kapalı" değil, "adres bilinmiyor" ölçülüyordu.
`direct` kipinde ise rota açık olduğu hâlde FAIL veriyordu.

IP artık test tarafından `kubectl get svc minio` ile bulunup sondaya
enjekte ediliyor. Ölçülen (bu commit'te canlı):

    proxy   52/52  ·  sandbox → minio (IP)  TimeoutError
    direct  53/53  ·  sandbox → minio (IP)  ULASILDI (kipin bilinen bedeli)

Belgelerdeki sayılar bu ölçüme getirildi (sunum s.11 ve s.4, §11.18).
Bölüm 2 başlığı hâlâ `load_artifact`'tan söz ediyordu → "çapraz girdi
BEYANLA"; modül docstring'indeki kontrol sayısı 38 → 52/53.

Co-Authored-By: Claude Opus 5 <noreply@anthropic.com>
</commit_message>
<xml_diff>
--- a/ptc_art/PTC_Sunum_Karsilastirma.pptx
+++ b/ptc_art/PTC_Sunum_Karsilastirma.pptx
@@ -11843,7 +11843,7 @@
                 <a:ea typeface="Inter" pitchFamily="34" charset="-122"/>
                 <a:cs typeface="Inter" pitchFamily="34" charset="-120"/>
               </a:rPr>
-              <a:t>209 test · 51/51 (`proxy`) + 52/52 (`direct`) canlı kabul kontrolü · bütün ölçümler cluster'dan.</a:t>
+              <a:t>209 test · 52/52 (`proxy`) + 53/53 (`direct`) canlı kabul kontrolü · bütün ölçümler cluster'dan.</a:t>
             </a:r>
             <a:endParaRPr lang="en-US" sz="1300" dirty="0"/>
           </a:p>
@@ -18449,6 +18449,20 @@
                         </a:rPr>
                         <a:t>sandbox → minio</a:t>
                       </a:r>
+                      <a:pPr indent="0" marL="0">
+                        <a:buNone/>
+                      </a:pPr>
+                      <a:r>
+                        <a:rPr lang="en-US" sz="1150" dirty="0">
+                          <a:solidFill>
+                            <a:srgbClr val="1D1D1F"/>
+                          </a:solidFill>
+                          <a:latin typeface="Inter" pitchFamily="34" charset="0"/>
+                          <a:ea typeface="Inter" pitchFamily="34" charset="-122"/>
+                          <a:cs typeface="Inter" pitchFamily="34" charset="-120"/>
+                        </a:rPr>
+                        <a:t> (IP ile)</a:t>
+                      </a:r>
                       <a:endParaRPr lang="en-US" sz="1150" dirty="0">
                         <a:latin typeface="Inter" charset="0"/>
                         <a:ea typeface="Inter" charset="0"/>
@@ -18515,7 +18529,7 @@
                           <a:ea typeface="Inter" pitchFamily="34" charset="-122"/>
                           <a:cs typeface="Inter" pitchFamily="34" charset="-120"/>
                         </a:rPr>
-                        <a:t>gaierror</a:t>
+                        <a:t>TimeoutError</a:t>
                       </a:r>
                       <a:endParaRPr lang="en-US" sz="1150" dirty="0">
                         <a:latin typeface="Inter" charset="0"/>
@@ -18583,7 +18597,7 @@
                           <a:ea typeface="Inter" pitchFamily="34" charset="-122"/>
                           <a:cs typeface="Inter" pitchFamily="34" charset="-120"/>
                         </a:rPr>
-                        <a:t>ULASTI</a:t>
+                        <a:t>ULASILDI</a:t>
                       </a:r>
                       <a:endParaRPr lang="en-US" sz="1150" dirty="0">
                         <a:latin typeface="Inter" charset="0"/>

</xml_diff>